<commit_message>
Add structural-evidence slide to Track 2 pitch deck (7 slides)
New slide 5 shows the bosutinib-Src co-crystal (PDB 4MXO) between the
drug-candidates slide and the scalability slide; renumbered the following
slide accordingly. Updated both video scripts (EN/ES) to match.

Co-Authored-By: Claude Sonnet 5 <noreply@anthropic.com>
</commit_message>
<xml_diff>
--- a/Track 2/pitch_deck.pptx
+++ b/Track 2/pitch_deck.pptx
@@ -11,9 +11,10 @@
     <p:sldId id="259" r:id="rId5"/>
     <p:sldId id="260" r:id="rId6"/>
     <p:sldId id="261" r:id="rId7"/>
+    <p:sldId id="262" r:id="rId8"/>
   </p:sldIdLst>
   <p:notesMasterIdLst>
-    <p:notesMasterId r:id="rId8"/>
+    <p:notesMasterId r:id="rId9"/>
   </p:notesMasterIdLst>
   <p:sldSz cx="12192000" cy="6858000"/>
   <p:notesSz cx="6858000" cy="12192000"/>
@@ -859,7 +860,7 @@
           <a:p>
             <a:r>
               <a:rPr lang="en-US" dirty="0"/>
-              <a:t>[2:20-2:50] This mechanism isn't unique to this one mutation. It generalizes to the other two known MVA genes, and to chromosomally unstable tumors more broadly - the same vulnerability has independently shown up in glioblastoma and prostate cancer research. The pipeline we used - phenotype, to mechanism, to literature-mined approved drugs - is reusable for the next undiagnosed case, not just this one.</a:t>
+              <a:t>We looked for direct structural proof that bosutinib actually engages its proposed target, rather than relying on a docking prediction. PDB entry 4MXO is an experimentally solved co-crystal structure of bosutinib bound to human Src kinase - exactly the mechanism Schukken et al. showed to be selectively toxic in spindle-checkpoint-deficient cells. A separate solved structure, 3UE4, confirms bosutinib also binds Abl kinase, its other established target.</a:t>
             </a:r>
             <a:endParaRPr lang="en-US" dirty="0"/>
           </a:p>
@@ -947,7 +948,7 @@
           <a:p>
             <a:r>
               <a:rPr lang="en-US" dirty="0"/>
-              <a:t>[2:50-3:00] These are hypotheses for follow-up, not proven treatments - validating them in this child's own cells is the obvious next step. But for a family that had no genetic answer six weeks ago, we think this is a real, testable place to start.</a:t>
+              <a:t>[2:20-2:50] This mechanism isn't unique to this one mutation. It generalizes to the other two known MVA genes, and to chromosomally unstable tumors more broadly - the same vulnerability has independently shown up in glioblastoma and prostate cancer research. The pipeline we used - phenotype, to mechanism, to literature-mined approved drugs - is reusable for the next undiagnosed case, not just this one.</a:t>
             </a:r>
             <a:endParaRPr lang="en-US" dirty="0"/>
           </a:p>
@@ -971,6 +972,94 @@
             <a:fld id="{F7021451-1387-4CA6-816F-3879F97B5CBC}" type="slidenum">
               <a:rPr lang="en-US"/>
               <a:t>6</a:t>
+            </a:fld>
+            <a:endParaRPr lang="en-US"/>
+          </a:p>
+        </p:txBody>
+      </p:sp>
+    </p:spTree>
+    <p:extLst>
+      <p:ext uri="{BB962C8B-B14F-4D97-AF65-F5344CB8AC3E}">
+        <p14:creationId xmlns:p14="http://schemas.microsoft.com/office/powerpoint/2010/main" val="1024086991"/>
+      </p:ext>
+    </p:extLst>
+  </p:cSld>
+  <p:clrMapOvr>
+    <a:masterClrMapping/>
+  </p:clrMapOvr>
+</p:notes>
+</file>
+
+<file path=ppt/notesSlides/notesSlide7.xml><?xml version="1.0" encoding="utf-8"?>
+<p:notes xmlns:a="http://schemas.openxmlformats.org/drawingml/2006/main" xmlns:r="http://schemas.openxmlformats.org/officeDocument/2006/relationships" xmlns:p="http://schemas.openxmlformats.org/presentationml/2006/main">
+  <p:cSld>
+    <p:spTree>
+      <p:nvGrpSpPr>
+        <p:cNvPr id="1" name=""/>
+        <p:cNvGrpSpPr/>
+        <p:nvPr/>
+      </p:nvGrpSpPr>
+      <p:grpSpPr>
+        <a:xfrm>
+          <a:off x="0" y="0"/>
+          <a:ext cx="0" cy="0"/>
+          <a:chOff x="0" y="0"/>
+          <a:chExt cx="0" cy="0"/>
+        </a:xfrm>
+      </p:grpSpPr>
+      <p:sp>
+        <p:nvSpPr>
+          <p:cNvPr id="2" name="Slide Image Placeholder 1"/>
+          <p:cNvSpPr>
+            <a:spLocks noGrp="1" noRot="1" noChangeAspect="1"/>
+          </p:cNvSpPr>
+          <p:nvPr>
+            <p:ph type="sldImg"/>
+          </p:nvPr>
+        </p:nvSpPr>
+        <p:spPr/>
+      </p:sp>
+      <p:sp>
+        <p:nvSpPr>
+          <p:cNvPr id="3" name="Notes Placeholder 2"/>
+          <p:cNvSpPr>
+            <a:spLocks noGrp="1"/>
+          </p:cNvSpPr>
+          <p:nvPr>
+            <p:ph type="body" idx="1"/>
+          </p:nvPr>
+        </p:nvSpPr>
+        <p:spPr/>
+        <p:txBody>
+          <a:bodyPr/>
+          <a:lstStyle/>
+          <a:p>
+            <a:r>
+              <a:rPr lang="en-US" dirty="0"/>
+              <a:t>[2:50-3:00] These are hypotheses for follow-up, not proven treatments - validating them in this child's own cells is the obvious next step. But for a family that had no genetic answer six weeks ago, we think this is a real, testable place to start.</a:t>
+            </a:r>
+            <a:endParaRPr lang="en-US" dirty="0"/>
+          </a:p>
+        </p:txBody>
+      </p:sp>
+      <p:sp>
+        <p:nvSpPr>
+          <p:cNvPr id="4" name="Slide Number Placeholder 3"/>
+          <p:cNvSpPr>
+            <a:spLocks noGrp="1"/>
+          </p:cNvSpPr>
+          <p:nvPr>
+            <p:ph type="sldNum" sz="quarter" idx="10"/>
+          </p:nvPr>
+        </p:nvSpPr>
+        <p:spPr/>
+        <p:txBody>
+          <a:bodyPr/>
+          <a:lstStyle/>
+          <a:p>
+            <a:fld id="{F7021451-1387-4CA6-816F-3879F97B5CBC}" type="slidenum">
+              <a:rPr lang="en-US"/>
+              <a:t>7</a:t>
             </a:fld>
             <a:endParaRPr lang="en-US"/>
           </a:p>
@@ -4648,7 +4737,7 @@
               <a:buNone/>
             </a:pPr>
             <a:r>
-              <a:rPr lang="en-US" sz="3000" b="1" dirty="0">
+              <a:rPr lang="en-US" sz="2800" b="1" dirty="0">
                 <a:solidFill>
                   <a:srgbClr val="1A2B2E"/>
                 </a:solidFill>
@@ -4656,42 +4745,105 @@
                 <a:ea typeface="Cambria" pitchFamily="34" charset="-122"/>
                 <a:cs typeface="Cambria" pitchFamily="34" charset="-120"/>
               </a:rPr>
-              <a:t>Beyond This One Child</a:t>
-            </a:r>
-            <a:endParaRPr lang="en-US" sz="3000" dirty="0"/>
-          </a:p>
-        </p:txBody>
-      </p:sp>
-      <p:sp>
-        <p:nvSpPr>
-          <p:cNvPr id="5" name="Shape 3"/>
+              <a:t>Not a Guess — A Solved Structure</a:t>
+            </a:r>
+            <a:endParaRPr lang="en-US" sz="2800" dirty="0"/>
+          </a:p>
+        </p:txBody>
+      </p:sp>
+      <p:sp>
+        <p:nvSpPr>
+          <p:cNvPr id="5" name="Text 3"/>
+          <p:cNvSpPr txBox="1"/>
+          <p:nvPr/>
+        </p:nvSpPr>
+        <p:spPr>
+          <a:xfrm>
+            <a:off x="1234440" y="960120"/>
+            <a:ext cx="9601200" cy="365760"/>
+          </a:xfrm>
+          <a:prstGeom prst="rect">
+            <a:avLst/>
+          </a:prstGeom>
+          <a:noFill/>
+          <a:ln/>
+        </p:spPr>
+        <p:txBody>
+          <a:bodyPr wrap="square" lIns="0" tIns="0" rIns="0" bIns="0" rtlCol="0" anchor="ctr"/>
+          <a:lstStyle/>
+          <a:p>
+            <a:pPr algn="l" indent="0" marL="0">
+              <a:buNone/>
+            </a:pPr>
+            <a:r>
+              <a:rPr lang="en-US" sz="1400" dirty="0">
+                <a:solidFill>
+                  <a:srgbClr val="4E6367"/>
+                </a:solidFill>
+                <a:latin typeface="Calibri" pitchFamily="34" charset="0"/>
+                <a:ea typeface="Calibri" pitchFamily="34" charset="-122"/>
+                <a:cs typeface="Calibri" pitchFamily="34" charset="-120"/>
+              </a:rPr>
+              <a:t>Confirming target engagement experimentally, not by prediction</a:t>
+            </a:r>
+            <a:endParaRPr lang="en-US" sz="1400" dirty="0"/>
+          </a:p>
+        </p:txBody>
+      </p:sp>
+      <p:pic>
+        <p:nvPicPr>
+          <p:cNvPr id="6" name="Image 0" descr="E:/2026 Escritorio/Hackaton 2025/Track 2/figures/bosutinib_src_cocrystal.png">    </p:cNvPr>
+          <p:cNvPicPr>
+            <a:picLocks noChangeAspect="1"/>
+          </p:cNvPicPr>
+          <p:nvPr/>
+        </p:nvPicPr>
+        <p:blipFill>
+          <a:blip r:embed="rId1"/>
+          <a:stretch>
+            <a:fillRect/>
+          </a:stretch>
+        </p:blipFill>
+        <p:spPr>
+          <a:xfrm>
+            <a:off x="640080" y="1463040"/>
+            <a:ext cx="6035040" cy="4937760"/>
+          </a:xfrm>
+          <a:prstGeom prst="rect">
+            <a:avLst/>
+          </a:prstGeom>
+        </p:spPr>
+      </p:pic>
+      <p:sp>
+        <p:nvSpPr>
+          <p:cNvPr id="7" name="Shape 4"/>
           <p:cNvSpPr/>
           <p:nvPr/>
         </p:nvSpPr>
         <p:spPr>
           <a:xfrm>
-            <a:off x="822960" y="1600200"/>
-            <a:ext cx="457200" cy="457200"/>
+            <a:off x="7040880" y="1600200"/>
+            <a:ext cx="384048" cy="384048"/>
           </a:xfrm>
           <a:prstGeom prst="ellipse">
             <a:avLst/>
           </a:prstGeom>
           <a:solidFill>
-            <a:srgbClr val="02C39A"/>
+            <a:srgbClr val="00A896"/>
           </a:solidFill>
           <a:ln/>
         </p:spPr>
       </p:sp>
       <p:sp>
         <p:nvSpPr>
-          <p:cNvPr id="6" name="Text 4"/>
-          <p:cNvSpPr txBox="1"/>
-          <p:nvPr/>
-        </p:nvSpPr>
-        <p:spPr>
-          <a:xfrm>
-            <a:off x="822960" y="1600200"/>
-            <a:ext cx="457200" cy="457200"/>
+          <p:cNvPr id="8" name="Text 5"/>
+          <p:cNvSpPr txBox="1"/>
+          <p:nvPr/>
+        </p:nvSpPr>
+        <p:spPr>
+          <a:xfrm>
+            <a:off x="7040880" y="1600200"/>
+            <a:ext cx="384048" cy="384048"/>
           </a:xfrm>
           <a:prstGeom prst="rect">
             <a:avLst/>
@@ -4707,7 +4859,7 @@
               <a:buNone/>
             </a:pPr>
             <a:r>
-              <a:rPr lang="en-US" sz="2000" b="1" dirty="0">
+              <a:rPr lang="en-US" sz="1500" b="1" dirty="0">
                 <a:solidFill>
                   <a:srgbClr val="FFFFFF"/>
                 </a:solidFill>
@@ -4715,22 +4867,22 @@
                 <a:ea typeface="Calibri" pitchFamily="34" charset="-122"/>
                 <a:cs typeface="Calibri" pitchFamily="34" charset="-120"/>
               </a:rPr>
-              <a:t>•</a:t>
-            </a:r>
-            <a:endParaRPr lang="en-US" sz="2000" dirty="0"/>
-          </a:p>
-        </p:txBody>
-      </p:sp>
-      <p:sp>
-        <p:nvSpPr>
-          <p:cNvPr id="7" name="Text 5"/>
-          <p:cNvSpPr txBox="1"/>
-          <p:nvPr/>
-        </p:nvSpPr>
-        <p:spPr>
-          <a:xfrm>
-            <a:off x="1508760" y="1554480"/>
-            <a:ext cx="9509760" cy="411480"/>
+              <a:t>✓</a:t>
+            </a:r>
+            <a:endParaRPr lang="en-US" sz="1500" dirty="0"/>
+          </a:p>
+        </p:txBody>
+      </p:sp>
+      <p:sp>
+        <p:nvSpPr>
+          <p:cNvPr id="9" name="Text 6"/>
+          <p:cNvSpPr txBox="1"/>
+          <p:nvPr/>
+        </p:nvSpPr>
+        <p:spPr>
+          <a:xfrm>
+            <a:off x="7589520" y="1554480"/>
+            <a:ext cx="4114800" cy="411480"/>
           </a:xfrm>
           <a:prstGeom prst="rect">
             <a:avLst/>
@@ -4746,7 +4898,7 @@
               <a:buNone/>
             </a:pPr>
             <a:r>
-              <a:rPr lang="en-US" sz="1700" b="1" dirty="0">
+              <a:rPr lang="en-US" sz="1500" b="1" dirty="0">
                 <a:solidFill>
                   <a:srgbClr val="1A2B2E"/>
                 </a:solidFill>
@@ -4754,22 +4906,22 @@
                 <a:ea typeface="Calibri" pitchFamily="34" charset="-122"/>
                 <a:cs typeface="Calibri" pitchFamily="34" charset="-120"/>
               </a:rPr>
-              <a:t>Generalizes to the other two MVA genes</a:t>
-            </a:r>
-            <a:endParaRPr lang="en-US" sz="1700" dirty="0"/>
-          </a:p>
-        </p:txBody>
-      </p:sp>
-      <p:sp>
-        <p:nvSpPr>
-          <p:cNvPr id="8" name="Text 6"/>
-          <p:cNvSpPr txBox="1"/>
-          <p:nvPr/>
-        </p:nvSpPr>
-        <p:spPr>
-          <a:xfrm>
-            <a:off x="1508760" y="1984248"/>
-            <a:ext cx="9509760" cy="685800"/>
+              <a:t>PDB 4MXO</a:t>
+            </a:r>
+            <a:endParaRPr lang="en-US" sz="1500" dirty="0"/>
+          </a:p>
+        </p:txBody>
+      </p:sp>
+      <p:sp>
+        <p:nvSpPr>
+          <p:cNvPr id="10" name="Text 7"/>
+          <p:cNvSpPr txBox="1"/>
+          <p:nvPr/>
+        </p:nvSpPr>
+        <p:spPr>
+          <a:xfrm>
+            <a:off x="7589520" y="1984248"/>
+            <a:ext cx="4114800" cy="914400"/>
           </a:xfrm>
           <a:prstGeom prst="rect">
             <a:avLst/>
@@ -4785,7 +4937,7 @@
               <a:buNone/>
             </a:pPr>
             <a:r>
-              <a:rPr lang="en-US" sz="1350" dirty="0">
+              <a:rPr lang="en-US" sz="1250" dirty="0">
                 <a:solidFill>
                   <a:srgbClr val="4E6367"/>
                 </a:solidFill>
@@ -4793,42 +4945,42 @@
                 <a:ea typeface="Calibri" pitchFamily="34" charset="-122"/>
                 <a:cs typeface="Calibri" pitchFamily="34" charset="-120"/>
               </a:rPr>
-              <a:t>CEP57 (MVA2) and TRIP13 (MVA3) converge on the same spindle-checkpoint pathway.</a:t>
-            </a:r>
-            <a:endParaRPr lang="en-US" sz="1350" dirty="0"/>
-          </a:p>
-        </p:txBody>
-      </p:sp>
-      <p:sp>
-        <p:nvSpPr>
-          <p:cNvPr id="9" name="Shape 7"/>
+              <a:t>Human Src kinase, experimentally solved bound to bosutinib — not a computational docking prediction.</a:t>
+            </a:r>
+            <a:endParaRPr lang="en-US" sz="1250" dirty="0"/>
+          </a:p>
+        </p:txBody>
+      </p:sp>
+      <p:sp>
+        <p:nvSpPr>
+          <p:cNvPr id="11" name="Shape 8"/>
           <p:cNvSpPr/>
           <p:nvPr/>
         </p:nvSpPr>
         <p:spPr>
           <a:xfrm>
-            <a:off x="822960" y="2880360"/>
-            <a:ext cx="457200" cy="457200"/>
+            <a:off x="7040880" y="3063240"/>
+            <a:ext cx="384048" cy="384048"/>
           </a:xfrm>
           <a:prstGeom prst="ellipse">
             <a:avLst/>
           </a:prstGeom>
           <a:solidFill>
-            <a:srgbClr val="02C39A"/>
+            <a:srgbClr val="00A896"/>
           </a:solidFill>
           <a:ln/>
         </p:spPr>
       </p:sp>
       <p:sp>
         <p:nvSpPr>
-          <p:cNvPr id="10" name="Text 8"/>
-          <p:cNvSpPr txBox="1"/>
-          <p:nvPr/>
-        </p:nvSpPr>
-        <p:spPr>
-          <a:xfrm>
-            <a:off x="822960" y="2880360"/>
-            <a:ext cx="457200" cy="457200"/>
+          <p:cNvPr id="12" name="Text 9"/>
+          <p:cNvSpPr txBox="1"/>
+          <p:nvPr/>
+        </p:nvSpPr>
+        <p:spPr>
+          <a:xfrm>
+            <a:off x="7040880" y="3063240"/>
+            <a:ext cx="384048" cy="384048"/>
           </a:xfrm>
           <a:prstGeom prst="rect">
             <a:avLst/>
@@ -4844,7 +4996,7 @@
               <a:buNone/>
             </a:pPr>
             <a:r>
-              <a:rPr lang="en-US" sz="2000" b="1" dirty="0">
+              <a:rPr lang="en-US" sz="1500" b="1" dirty="0">
                 <a:solidFill>
                   <a:srgbClr val="FFFFFF"/>
                 </a:solidFill>
@@ -4852,22 +5004,22 @@
                 <a:ea typeface="Calibri" pitchFamily="34" charset="-122"/>
                 <a:cs typeface="Calibri" pitchFamily="34" charset="-120"/>
               </a:rPr>
-              <a:t>•</a:t>
-            </a:r>
-            <a:endParaRPr lang="en-US" sz="2000" dirty="0"/>
-          </a:p>
-        </p:txBody>
-      </p:sp>
-      <p:sp>
-        <p:nvSpPr>
-          <p:cNvPr id="11" name="Text 9"/>
-          <p:cNvSpPr txBox="1"/>
-          <p:nvPr/>
-        </p:nvSpPr>
-        <p:spPr>
-          <a:xfrm>
-            <a:off x="1508760" y="2834640"/>
-            <a:ext cx="9509760" cy="411480"/>
+              <a:t>✓</a:t>
+            </a:r>
+            <a:endParaRPr lang="en-US" sz="1500" dirty="0"/>
+          </a:p>
+        </p:txBody>
+      </p:sp>
+      <p:sp>
+        <p:nvSpPr>
+          <p:cNvPr id="13" name="Text 10"/>
+          <p:cNvSpPr txBox="1"/>
+          <p:nvPr/>
+        </p:nvSpPr>
+        <p:spPr>
+          <a:xfrm>
+            <a:off x="7589520" y="3017520"/>
+            <a:ext cx="4114800" cy="411480"/>
           </a:xfrm>
           <a:prstGeom prst="rect">
             <a:avLst/>
@@ -4883,7 +5035,7 @@
               <a:buNone/>
             </a:pPr>
             <a:r>
-              <a:rPr lang="en-US" sz="1700" b="1" dirty="0">
+              <a:rPr lang="en-US" sz="1500" b="1" dirty="0">
                 <a:solidFill>
                   <a:srgbClr val="1A2B2E"/>
                 </a:solidFill>
@@ -4891,22 +5043,22 @@
                 <a:ea typeface="Calibri" pitchFamily="34" charset="-122"/>
                 <a:cs typeface="Calibri" pitchFamily="34" charset="-120"/>
               </a:rPr>
-              <a:t>Generalizes to chromosomally unstable tumors broadly</a:t>
-            </a:r>
-            <a:endParaRPr lang="en-US" sz="1700" dirty="0"/>
-          </a:p>
-        </p:txBody>
-      </p:sp>
-      <p:sp>
-        <p:nvSpPr>
-          <p:cNvPr id="12" name="Text 10"/>
-          <p:cNvSpPr txBox="1"/>
-          <p:nvPr/>
-        </p:nvSpPr>
-        <p:spPr>
-          <a:xfrm>
-            <a:off x="1508760" y="3264408"/>
-            <a:ext cx="9509760" cy="685800"/>
+              <a:t>Confirms the exact mechanism</a:t>
+            </a:r>
+            <a:endParaRPr lang="en-US" sz="1500" dirty="0"/>
+          </a:p>
+        </p:txBody>
+      </p:sp>
+      <p:sp>
+        <p:nvSpPr>
+          <p:cNvPr id="14" name="Text 11"/>
+          <p:cNvSpPr txBox="1"/>
+          <p:nvPr/>
+        </p:nvSpPr>
+        <p:spPr>
+          <a:xfrm>
+            <a:off x="7589520" y="3447288"/>
+            <a:ext cx="4114800" cy="914400"/>
           </a:xfrm>
           <a:prstGeom prst="rect">
             <a:avLst/>
@@ -4922,7 +5074,7 @@
               <a:buNone/>
             </a:pPr>
             <a:r>
-              <a:rPr lang="en-US" sz="1350" dirty="0">
+              <a:rPr lang="en-US" sz="1250" dirty="0">
                 <a:solidFill>
                   <a:srgbClr val="4E6367"/>
                 </a:solidFill>
@@ -4930,42 +5082,42 @@
                 <a:ea typeface="Calibri" pitchFamily="34" charset="-122"/>
                 <a:cs typeface="Calibri" pitchFamily="34" charset="-120"/>
               </a:rPr>
-              <a:t>BUB1B/BUBR1 dependency independently reported in glioblastoma (Ding et al. 2012) and prostate cancer (Martinez et al. 2025).</a:t>
-            </a:r>
-            <a:endParaRPr lang="en-US" sz="1350" dirty="0"/>
-          </a:p>
-        </p:txBody>
-      </p:sp>
-      <p:sp>
-        <p:nvSpPr>
-          <p:cNvPr id="13" name="Shape 11"/>
+              <a:t>The same Src engagement Schukken et al. (2020) showed to be selectively lethal in spindle-checkpoint-deficient cells.</a:t>
+            </a:r>
+            <a:endParaRPr lang="en-US" sz="1250" dirty="0"/>
+          </a:p>
+        </p:txBody>
+      </p:sp>
+      <p:sp>
+        <p:nvSpPr>
+          <p:cNvPr id="15" name="Shape 12"/>
           <p:cNvSpPr/>
           <p:nvPr/>
         </p:nvSpPr>
         <p:spPr>
           <a:xfrm>
-            <a:off x="822960" y="4160520"/>
-            <a:ext cx="457200" cy="457200"/>
+            <a:off x="7040880" y="4526280"/>
+            <a:ext cx="384048" cy="384048"/>
           </a:xfrm>
           <a:prstGeom prst="ellipse">
             <a:avLst/>
           </a:prstGeom>
           <a:solidFill>
-            <a:srgbClr val="02C39A"/>
+            <a:srgbClr val="00A896"/>
           </a:solidFill>
           <a:ln/>
         </p:spPr>
       </p:sp>
       <p:sp>
         <p:nvSpPr>
-          <p:cNvPr id="14" name="Text 12"/>
-          <p:cNvSpPr txBox="1"/>
-          <p:nvPr/>
-        </p:nvSpPr>
-        <p:spPr>
-          <a:xfrm>
-            <a:off x="822960" y="4160520"/>
-            <a:ext cx="457200" cy="457200"/>
+          <p:cNvPr id="16" name="Text 13"/>
+          <p:cNvSpPr txBox="1"/>
+          <p:nvPr/>
+        </p:nvSpPr>
+        <p:spPr>
+          <a:xfrm>
+            <a:off x="7040880" y="4526280"/>
+            <a:ext cx="384048" cy="384048"/>
           </a:xfrm>
           <a:prstGeom prst="rect">
             <a:avLst/>
@@ -4981,7 +5133,7 @@
               <a:buNone/>
             </a:pPr>
             <a:r>
-              <a:rPr lang="en-US" sz="2000" b="1" dirty="0">
+              <a:rPr lang="en-US" sz="1500" b="1" dirty="0">
                 <a:solidFill>
                   <a:srgbClr val="FFFFFF"/>
                 </a:solidFill>
@@ -4989,22 +5141,22 @@
                 <a:ea typeface="Calibri" pitchFamily="34" charset="-122"/>
                 <a:cs typeface="Calibri" pitchFamily="34" charset="-120"/>
               </a:rPr>
-              <a:t>•</a:t>
-            </a:r>
-            <a:endParaRPr lang="en-US" sz="2000" dirty="0"/>
-          </a:p>
-        </p:txBody>
-      </p:sp>
-      <p:sp>
-        <p:nvSpPr>
-          <p:cNvPr id="15" name="Text 13"/>
-          <p:cNvSpPr txBox="1"/>
-          <p:nvPr/>
-        </p:nvSpPr>
-        <p:spPr>
-          <a:xfrm>
-            <a:off x="1508760" y="4114800"/>
-            <a:ext cx="9509760" cy="411480"/>
+              <a:t>✓</a:t>
+            </a:r>
+            <a:endParaRPr lang="en-US" sz="1500" dirty="0"/>
+          </a:p>
+        </p:txBody>
+      </p:sp>
+      <p:sp>
+        <p:nvSpPr>
+          <p:cNvPr id="17" name="Text 14"/>
+          <p:cNvSpPr txBox="1"/>
+          <p:nvPr/>
+        </p:nvSpPr>
+        <p:spPr>
+          <a:xfrm>
+            <a:off x="7589520" y="4480560"/>
+            <a:ext cx="4114800" cy="411480"/>
           </a:xfrm>
           <a:prstGeom prst="rect">
             <a:avLst/>
@@ -5020,7 +5172,7 @@
               <a:buNone/>
             </a:pPr>
             <a:r>
-              <a:rPr lang="en-US" sz="1700" b="1" dirty="0">
+              <a:rPr lang="en-US" sz="1500" b="1" dirty="0">
                 <a:solidFill>
                   <a:srgbClr val="1A2B2E"/>
                 </a:solidFill>
@@ -5028,22 +5180,22 @@
                 <a:ea typeface="Calibri" pitchFamily="34" charset="-122"/>
                 <a:cs typeface="Calibri" pitchFamily="34" charset="-120"/>
               </a:rPr>
-              <a:t>A reusable pipeline, not a one-off</a:t>
-            </a:r>
-            <a:endParaRPr lang="en-US" sz="1700" dirty="0"/>
-          </a:p>
-        </p:txBody>
-      </p:sp>
-      <p:sp>
-        <p:nvSpPr>
-          <p:cNvPr id="16" name="Text 14"/>
-          <p:cNvSpPr txBox="1"/>
-          <p:nvPr/>
-        </p:nvSpPr>
-        <p:spPr>
-          <a:xfrm>
-            <a:off x="1508760" y="4544568"/>
-            <a:ext cx="9509760" cy="685800"/>
+              <a:t>PDB 3UE4</a:t>
+            </a:r>
+            <a:endParaRPr lang="en-US" sz="1500" dirty="0"/>
+          </a:p>
+        </p:txBody>
+      </p:sp>
+      <p:sp>
+        <p:nvSpPr>
+          <p:cNvPr id="18" name="Text 15"/>
+          <p:cNvSpPr txBox="1"/>
+          <p:nvPr/>
+        </p:nvSpPr>
+        <p:spPr>
+          <a:xfrm>
+            <a:off x="7589520" y="4910328"/>
+            <a:ext cx="4114800" cy="914400"/>
           </a:xfrm>
           <a:prstGeom prst="rect">
             <a:avLst/>
@@ -5059,7 +5211,7 @@
               <a:buNone/>
             </a:pPr>
             <a:r>
-              <a:rPr lang="en-US" sz="1350" dirty="0">
+              <a:rPr lang="en-US" sz="1250" dirty="0">
                 <a:solidFill>
                   <a:srgbClr val="4E6367"/>
                 </a:solidFill>
@@ -5067,44 +5219,44 @@
                 <a:ea typeface="Calibri" pitchFamily="34" charset="-122"/>
                 <a:cs typeface="Calibri" pitchFamily="34" charset="-120"/>
               </a:rPr>
-              <a:t>Phenotype → mechanism → literature-mined approved drugs — directly applicable to the next undiagnosed rare-disease case.</a:t>
-            </a:r>
-            <a:endParaRPr lang="en-US" sz="1350" dirty="0"/>
-          </a:p>
-        </p:txBody>
-      </p:sp>
-      <p:sp>
-        <p:nvSpPr>
-          <p:cNvPr id="17" name="Shape 15"/>
+              <a:t>Bosutinib is also independently solved bound to Abl kinase, its other established target.</a:t>
+            </a:r>
+            <a:endParaRPr lang="en-US" sz="1250" dirty="0"/>
+          </a:p>
+        </p:txBody>
+      </p:sp>
+      <p:sp>
+        <p:nvSpPr>
+          <p:cNvPr id="19" name="Shape 16"/>
           <p:cNvSpPr/>
           <p:nvPr/>
         </p:nvSpPr>
         <p:spPr>
           <a:xfrm>
-            <a:off x="731520" y="5623560"/>
-            <a:ext cx="10698480" cy="777240"/>
+            <a:off x="7040880" y="5806440"/>
+            <a:ext cx="4572000" cy="594360"/>
           </a:xfrm>
           <a:prstGeom prst="roundRect">
             <a:avLst>
-              <a:gd name="adj" fmla="val 11765"/>
+              <a:gd name="adj" fmla="val 15385"/>
             </a:avLst>
           </a:prstGeom>
           <a:solidFill>
-            <a:srgbClr val="D9F0EE"/>
+            <a:srgbClr val="F2F9F8"/>
           </a:solidFill>
           <a:ln/>
         </p:spPr>
       </p:sp>
       <p:sp>
         <p:nvSpPr>
-          <p:cNvPr id="18" name="Text 16"/>
-          <p:cNvSpPr txBox="1"/>
-          <p:nvPr/>
-        </p:nvSpPr>
-        <p:spPr>
-          <a:xfrm>
-            <a:off x="1005840" y="5623560"/>
-            <a:ext cx="10149840" cy="777240"/>
+          <p:cNvPr id="20" name="Text 17"/>
+          <p:cNvSpPr txBox="1"/>
+          <p:nvPr/>
+        </p:nvSpPr>
+        <p:spPr>
+          <a:xfrm>
+            <a:off x="7223760" y="5806440"/>
+            <a:ext cx="4297680" cy="594360"/>
           </a:xfrm>
           <a:prstGeom prst="rect">
             <a:avLst/>
@@ -5120,7 +5272,7 @@
               <a:buNone/>
             </a:pPr>
             <a:r>
-              <a:rPr lang="en-US" sz="1250" i="1" dirty="0">
+              <a:rPr lang="en-US" sz="1100" i="1" dirty="0">
                 <a:solidFill>
                   <a:srgbClr val="028090"/>
                 </a:solidFill>
@@ -5128,9 +5280,9 @@
                 <a:ea typeface="Calibri" pitchFamily="34" charset="-122"/>
                 <a:cs typeface="Calibri" pitchFamily="34" charset="-120"/>
               </a:rPr>
-              <a:t>Same triage logic already found this compound-het pair independently confirmed by ~20 other teams in this hackathon.</a:t>
-            </a:r>
-            <a:endParaRPr lang="en-US" sz="1250" dirty="0"/>
+              <a:t>A solved structure is stronger evidence of compatibility than docking would be.</a:t>
+            </a:r>
+            <a:endParaRPr lang="en-US" sz="1100" dirty="0"/>
           </a:p>
         </p:txBody>
       </p:sp>
@@ -5145,6 +5297,608 @@
 <file path=ppt/slides/slide6.xml><?xml version="1.0" encoding="utf-8"?>
 <p:sld xmlns:a="http://schemas.openxmlformats.org/drawingml/2006/main" xmlns:r="http://schemas.openxmlformats.org/officeDocument/2006/relationships" xmlns:p="http://schemas.openxmlformats.org/presentationml/2006/main">
   <p:cSld name="Slide 6">
+    <p:bg>
+      <p:bgPr>
+        <a:solidFill>
+          <a:srgbClr val="FFFFFF"/>
+        </a:solidFill>
+      </p:bgPr>
+    </p:bg>
+    <p:spTree>
+      <p:nvGrpSpPr>
+        <p:cNvPr id="1" name=""/>
+        <p:cNvGrpSpPr/>
+        <p:nvPr/>
+      </p:nvGrpSpPr>
+      <p:grpSpPr>
+        <a:xfrm>
+          <a:off x="0" y="0"/>
+          <a:ext cx="0" cy="0"/>
+          <a:chOff x="0" y="0"/>
+          <a:chExt cx="0" cy="0"/>
+        </a:xfrm>
+      </p:grpSpPr>
+      <p:sp>
+        <p:nvSpPr>
+          <p:cNvPr id="2" name="Shape 0"/>
+          <p:cNvSpPr/>
+          <p:nvPr/>
+        </p:nvSpPr>
+        <p:spPr>
+          <a:xfrm>
+            <a:off x="548640" y="502920"/>
+            <a:ext cx="457200" cy="457200"/>
+          </a:xfrm>
+          <a:prstGeom prst="ellipse">
+            <a:avLst/>
+          </a:prstGeom>
+          <a:solidFill>
+            <a:srgbClr val="028090"/>
+          </a:solidFill>
+          <a:ln/>
+        </p:spPr>
+      </p:sp>
+      <p:sp>
+        <p:nvSpPr>
+          <p:cNvPr id="3" name="Text 1"/>
+          <p:cNvSpPr txBox="1"/>
+          <p:nvPr/>
+        </p:nvSpPr>
+        <p:spPr>
+          <a:xfrm>
+            <a:off x="548640" y="502920"/>
+            <a:ext cx="457200" cy="457200"/>
+          </a:xfrm>
+          <a:prstGeom prst="rect">
+            <a:avLst/>
+          </a:prstGeom>
+          <a:noFill/>
+          <a:ln/>
+        </p:spPr>
+        <p:txBody>
+          <a:bodyPr wrap="square" lIns="0" tIns="0" rIns="0" bIns="0" rtlCol="0" anchor="ctr"/>
+          <a:lstStyle/>
+          <a:p>
+            <a:pPr algn="ctr" indent="0" marL="0">
+              <a:buNone/>
+            </a:pPr>
+            <a:r>
+              <a:rPr lang="en-US" sz="1800" b="1" dirty="0">
+                <a:solidFill>
+                  <a:srgbClr val="FFFFFF"/>
+                </a:solidFill>
+                <a:latin typeface="Calibri" pitchFamily="34" charset="0"/>
+                <a:ea typeface="Calibri" pitchFamily="34" charset="-122"/>
+                <a:cs typeface="Calibri" pitchFamily="34" charset="-120"/>
+              </a:rPr>
+              <a:t>6</a:t>
+            </a:r>
+            <a:endParaRPr lang="en-US" sz="1800" dirty="0"/>
+          </a:p>
+        </p:txBody>
+      </p:sp>
+      <p:sp>
+        <p:nvSpPr>
+          <p:cNvPr id="4" name="Text 2"/>
+          <p:cNvSpPr txBox="1"/>
+          <p:nvPr/>
+        </p:nvSpPr>
+        <p:spPr>
+          <a:xfrm>
+            <a:off x="1234440" y="438912"/>
+            <a:ext cx="9601200" cy="594360"/>
+          </a:xfrm>
+          <a:prstGeom prst="rect">
+            <a:avLst/>
+          </a:prstGeom>
+          <a:noFill/>
+          <a:ln/>
+        </p:spPr>
+        <p:txBody>
+          <a:bodyPr wrap="square" lIns="0" tIns="0" rIns="0" bIns="0" rtlCol="0" anchor="ctr"/>
+          <a:lstStyle/>
+          <a:p>
+            <a:pPr algn="l" indent="0" marL="0">
+              <a:buNone/>
+            </a:pPr>
+            <a:r>
+              <a:rPr lang="en-US" sz="3000" b="1" dirty="0">
+                <a:solidFill>
+                  <a:srgbClr val="1A2B2E"/>
+                </a:solidFill>
+                <a:latin typeface="Cambria" pitchFamily="34" charset="0"/>
+                <a:ea typeface="Cambria" pitchFamily="34" charset="-122"/>
+                <a:cs typeface="Cambria" pitchFamily="34" charset="-120"/>
+              </a:rPr>
+              <a:t>Beyond This One Child</a:t>
+            </a:r>
+            <a:endParaRPr lang="en-US" sz="3000" dirty="0"/>
+          </a:p>
+        </p:txBody>
+      </p:sp>
+      <p:sp>
+        <p:nvSpPr>
+          <p:cNvPr id="5" name="Shape 3"/>
+          <p:cNvSpPr/>
+          <p:nvPr/>
+        </p:nvSpPr>
+        <p:spPr>
+          <a:xfrm>
+            <a:off x="822960" y="1600200"/>
+            <a:ext cx="457200" cy="457200"/>
+          </a:xfrm>
+          <a:prstGeom prst="ellipse">
+            <a:avLst/>
+          </a:prstGeom>
+          <a:solidFill>
+            <a:srgbClr val="02C39A"/>
+          </a:solidFill>
+          <a:ln/>
+        </p:spPr>
+      </p:sp>
+      <p:sp>
+        <p:nvSpPr>
+          <p:cNvPr id="6" name="Text 4"/>
+          <p:cNvSpPr txBox="1"/>
+          <p:nvPr/>
+        </p:nvSpPr>
+        <p:spPr>
+          <a:xfrm>
+            <a:off x="822960" y="1600200"/>
+            <a:ext cx="457200" cy="457200"/>
+          </a:xfrm>
+          <a:prstGeom prst="rect">
+            <a:avLst/>
+          </a:prstGeom>
+          <a:noFill/>
+          <a:ln/>
+        </p:spPr>
+        <p:txBody>
+          <a:bodyPr wrap="square" lIns="0" tIns="0" rIns="0" bIns="0" rtlCol="0" anchor="ctr"/>
+          <a:lstStyle/>
+          <a:p>
+            <a:pPr algn="ctr" indent="0" marL="0">
+              <a:buNone/>
+            </a:pPr>
+            <a:r>
+              <a:rPr lang="en-US" sz="2000" b="1" dirty="0">
+                <a:solidFill>
+                  <a:srgbClr val="FFFFFF"/>
+                </a:solidFill>
+                <a:latin typeface="Calibri" pitchFamily="34" charset="0"/>
+                <a:ea typeface="Calibri" pitchFamily="34" charset="-122"/>
+                <a:cs typeface="Calibri" pitchFamily="34" charset="-120"/>
+              </a:rPr>
+              <a:t>•</a:t>
+            </a:r>
+            <a:endParaRPr lang="en-US" sz="2000" dirty="0"/>
+          </a:p>
+        </p:txBody>
+      </p:sp>
+      <p:sp>
+        <p:nvSpPr>
+          <p:cNvPr id="7" name="Text 5"/>
+          <p:cNvSpPr txBox="1"/>
+          <p:nvPr/>
+        </p:nvSpPr>
+        <p:spPr>
+          <a:xfrm>
+            <a:off x="1508760" y="1554480"/>
+            <a:ext cx="9509760" cy="411480"/>
+          </a:xfrm>
+          <a:prstGeom prst="rect">
+            <a:avLst/>
+          </a:prstGeom>
+          <a:noFill/>
+          <a:ln/>
+        </p:spPr>
+        <p:txBody>
+          <a:bodyPr wrap="square" lIns="0" tIns="0" rIns="0" bIns="0" rtlCol="0" anchor="ctr"/>
+          <a:lstStyle/>
+          <a:p>
+            <a:pPr algn="l" indent="0" marL="0">
+              <a:buNone/>
+            </a:pPr>
+            <a:r>
+              <a:rPr lang="en-US" sz="1700" b="1" dirty="0">
+                <a:solidFill>
+                  <a:srgbClr val="1A2B2E"/>
+                </a:solidFill>
+                <a:latin typeface="Calibri" pitchFamily="34" charset="0"/>
+                <a:ea typeface="Calibri" pitchFamily="34" charset="-122"/>
+                <a:cs typeface="Calibri" pitchFamily="34" charset="-120"/>
+              </a:rPr>
+              <a:t>Generalizes to the other two MVA genes</a:t>
+            </a:r>
+            <a:endParaRPr lang="en-US" sz="1700" dirty="0"/>
+          </a:p>
+        </p:txBody>
+      </p:sp>
+      <p:sp>
+        <p:nvSpPr>
+          <p:cNvPr id="8" name="Text 6"/>
+          <p:cNvSpPr txBox="1"/>
+          <p:nvPr/>
+        </p:nvSpPr>
+        <p:spPr>
+          <a:xfrm>
+            <a:off x="1508760" y="1984248"/>
+            <a:ext cx="9509760" cy="685800"/>
+          </a:xfrm>
+          <a:prstGeom prst="rect">
+            <a:avLst/>
+          </a:prstGeom>
+          <a:noFill/>
+          <a:ln/>
+        </p:spPr>
+        <p:txBody>
+          <a:bodyPr wrap="square" lIns="0" tIns="0" rIns="0" bIns="0" rtlCol="0" anchor="ctr"/>
+          <a:lstStyle/>
+          <a:p>
+            <a:pPr algn="l" indent="0" marL="0">
+              <a:buNone/>
+            </a:pPr>
+            <a:r>
+              <a:rPr lang="en-US" sz="1350" dirty="0">
+                <a:solidFill>
+                  <a:srgbClr val="4E6367"/>
+                </a:solidFill>
+                <a:latin typeface="Calibri" pitchFamily="34" charset="0"/>
+                <a:ea typeface="Calibri" pitchFamily="34" charset="-122"/>
+                <a:cs typeface="Calibri" pitchFamily="34" charset="-120"/>
+              </a:rPr>
+              <a:t>CEP57 (MVA2) and TRIP13 (MVA3) converge on the same spindle-checkpoint pathway.</a:t>
+            </a:r>
+            <a:endParaRPr lang="en-US" sz="1350" dirty="0"/>
+          </a:p>
+        </p:txBody>
+      </p:sp>
+      <p:sp>
+        <p:nvSpPr>
+          <p:cNvPr id="9" name="Shape 7"/>
+          <p:cNvSpPr/>
+          <p:nvPr/>
+        </p:nvSpPr>
+        <p:spPr>
+          <a:xfrm>
+            <a:off x="822960" y="2880360"/>
+            <a:ext cx="457200" cy="457200"/>
+          </a:xfrm>
+          <a:prstGeom prst="ellipse">
+            <a:avLst/>
+          </a:prstGeom>
+          <a:solidFill>
+            <a:srgbClr val="02C39A"/>
+          </a:solidFill>
+          <a:ln/>
+        </p:spPr>
+      </p:sp>
+      <p:sp>
+        <p:nvSpPr>
+          <p:cNvPr id="10" name="Text 8"/>
+          <p:cNvSpPr txBox="1"/>
+          <p:nvPr/>
+        </p:nvSpPr>
+        <p:spPr>
+          <a:xfrm>
+            <a:off x="822960" y="2880360"/>
+            <a:ext cx="457200" cy="457200"/>
+          </a:xfrm>
+          <a:prstGeom prst="rect">
+            <a:avLst/>
+          </a:prstGeom>
+          <a:noFill/>
+          <a:ln/>
+        </p:spPr>
+        <p:txBody>
+          <a:bodyPr wrap="square" lIns="0" tIns="0" rIns="0" bIns="0" rtlCol="0" anchor="ctr"/>
+          <a:lstStyle/>
+          <a:p>
+            <a:pPr algn="ctr" indent="0" marL="0">
+              <a:buNone/>
+            </a:pPr>
+            <a:r>
+              <a:rPr lang="en-US" sz="2000" b="1" dirty="0">
+                <a:solidFill>
+                  <a:srgbClr val="FFFFFF"/>
+                </a:solidFill>
+                <a:latin typeface="Calibri" pitchFamily="34" charset="0"/>
+                <a:ea typeface="Calibri" pitchFamily="34" charset="-122"/>
+                <a:cs typeface="Calibri" pitchFamily="34" charset="-120"/>
+              </a:rPr>
+              <a:t>•</a:t>
+            </a:r>
+            <a:endParaRPr lang="en-US" sz="2000" dirty="0"/>
+          </a:p>
+        </p:txBody>
+      </p:sp>
+      <p:sp>
+        <p:nvSpPr>
+          <p:cNvPr id="11" name="Text 9"/>
+          <p:cNvSpPr txBox="1"/>
+          <p:nvPr/>
+        </p:nvSpPr>
+        <p:spPr>
+          <a:xfrm>
+            <a:off x="1508760" y="2834640"/>
+            <a:ext cx="9509760" cy="411480"/>
+          </a:xfrm>
+          <a:prstGeom prst="rect">
+            <a:avLst/>
+          </a:prstGeom>
+          <a:noFill/>
+          <a:ln/>
+        </p:spPr>
+        <p:txBody>
+          <a:bodyPr wrap="square" lIns="0" tIns="0" rIns="0" bIns="0" rtlCol="0" anchor="ctr"/>
+          <a:lstStyle/>
+          <a:p>
+            <a:pPr algn="l" indent="0" marL="0">
+              <a:buNone/>
+            </a:pPr>
+            <a:r>
+              <a:rPr lang="en-US" sz="1700" b="1" dirty="0">
+                <a:solidFill>
+                  <a:srgbClr val="1A2B2E"/>
+                </a:solidFill>
+                <a:latin typeface="Calibri" pitchFamily="34" charset="0"/>
+                <a:ea typeface="Calibri" pitchFamily="34" charset="-122"/>
+                <a:cs typeface="Calibri" pitchFamily="34" charset="-120"/>
+              </a:rPr>
+              <a:t>Generalizes to chromosomally unstable tumors broadly</a:t>
+            </a:r>
+            <a:endParaRPr lang="en-US" sz="1700" dirty="0"/>
+          </a:p>
+        </p:txBody>
+      </p:sp>
+      <p:sp>
+        <p:nvSpPr>
+          <p:cNvPr id="12" name="Text 10"/>
+          <p:cNvSpPr txBox="1"/>
+          <p:nvPr/>
+        </p:nvSpPr>
+        <p:spPr>
+          <a:xfrm>
+            <a:off x="1508760" y="3264408"/>
+            <a:ext cx="9509760" cy="685800"/>
+          </a:xfrm>
+          <a:prstGeom prst="rect">
+            <a:avLst/>
+          </a:prstGeom>
+          <a:noFill/>
+          <a:ln/>
+        </p:spPr>
+        <p:txBody>
+          <a:bodyPr wrap="square" lIns="0" tIns="0" rIns="0" bIns="0" rtlCol="0" anchor="ctr"/>
+          <a:lstStyle/>
+          <a:p>
+            <a:pPr algn="l" indent="0" marL="0">
+              <a:buNone/>
+            </a:pPr>
+            <a:r>
+              <a:rPr lang="en-US" sz="1350" dirty="0">
+                <a:solidFill>
+                  <a:srgbClr val="4E6367"/>
+                </a:solidFill>
+                <a:latin typeface="Calibri" pitchFamily="34" charset="0"/>
+                <a:ea typeface="Calibri" pitchFamily="34" charset="-122"/>
+                <a:cs typeface="Calibri" pitchFamily="34" charset="-120"/>
+              </a:rPr>
+              <a:t>BUB1B/BUBR1 dependency independently reported in glioblastoma (Ding et al. 2012) and prostate cancer (Martinez et al. 2025).</a:t>
+            </a:r>
+            <a:endParaRPr lang="en-US" sz="1350" dirty="0"/>
+          </a:p>
+        </p:txBody>
+      </p:sp>
+      <p:sp>
+        <p:nvSpPr>
+          <p:cNvPr id="13" name="Shape 11"/>
+          <p:cNvSpPr/>
+          <p:nvPr/>
+        </p:nvSpPr>
+        <p:spPr>
+          <a:xfrm>
+            <a:off x="822960" y="4160520"/>
+            <a:ext cx="457200" cy="457200"/>
+          </a:xfrm>
+          <a:prstGeom prst="ellipse">
+            <a:avLst/>
+          </a:prstGeom>
+          <a:solidFill>
+            <a:srgbClr val="02C39A"/>
+          </a:solidFill>
+          <a:ln/>
+        </p:spPr>
+      </p:sp>
+      <p:sp>
+        <p:nvSpPr>
+          <p:cNvPr id="14" name="Text 12"/>
+          <p:cNvSpPr txBox="1"/>
+          <p:nvPr/>
+        </p:nvSpPr>
+        <p:spPr>
+          <a:xfrm>
+            <a:off x="822960" y="4160520"/>
+            <a:ext cx="457200" cy="457200"/>
+          </a:xfrm>
+          <a:prstGeom prst="rect">
+            <a:avLst/>
+          </a:prstGeom>
+          <a:noFill/>
+          <a:ln/>
+        </p:spPr>
+        <p:txBody>
+          <a:bodyPr wrap="square" lIns="0" tIns="0" rIns="0" bIns="0" rtlCol="0" anchor="ctr"/>
+          <a:lstStyle/>
+          <a:p>
+            <a:pPr algn="ctr" indent="0" marL="0">
+              <a:buNone/>
+            </a:pPr>
+            <a:r>
+              <a:rPr lang="en-US" sz="2000" b="1" dirty="0">
+                <a:solidFill>
+                  <a:srgbClr val="FFFFFF"/>
+                </a:solidFill>
+                <a:latin typeface="Calibri" pitchFamily="34" charset="0"/>
+                <a:ea typeface="Calibri" pitchFamily="34" charset="-122"/>
+                <a:cs typeface="Calibri" pitchFamily="34" charset="-120"/>
+              </a:rPr>
+              <a:t>•</a:t>
+            </a:r>
+            <a:endParaRPr lang="en-US" sz="2000" dirty="0"/>
+          </a:p>
+        </p:txBody>
+      </p:sp>
+      <p:sp>
+        <p:nvSpPr>
+          <p:cNvPr id="15" name="Text 13"/>
+          <p:cNvSpPr txBox="1"/>
+          <p:nvPr/>
+        </p:nvSpPr>
+        <p:spPr>
+          <a:xfrm>
+            <a:off x="1508760" y="4114800"/>
+            <a:ext cx="9509760" cy="411480"/>
+          </a:xfrm>
+          <a:prstGeom prst="rect">
+            <a:avLst/>
+          </a:prstGeom>
+          <a:noFill/>
+          <a:ln/>
+        </p:spPr>
+        <p:txBody>
+          <a:bodyPr wrap="square" lIns="0" tIns="0" rIns="0" bIns="0" rtlCol="0" anchor="ctr"/>
+          <a:lstStyle/>
+          <a:p>
+            <a:pPr algn="l" indent="0" marL="0">
+              <a:buNone/>
+            </a:pPr>
+            <a:r>
+              <a:rPr lang="en-US" sz="1700" b="1" dirty="0">
+                <a:solidFill>
+                  <a:srgbClr val="1A2B2E"/>
+                </a:solidFill>
+                <a:latin typeface="Calibri" pitchFamily="34" charset="0"/>
+                <a:ea typeface="Calibri" pitchFamily="34" charset="-122"/>
+                <a:cs typeface="Calibri" pitchFamily="34" charset="-120"/>
+              </a:rPr>
+              <a:t>A reusable pipeline, not a one-off</a:t>
+            </a:r>
+            <a:endParaRPr lang="en-US" sz="1700" dirty="0"/>
+          </a:p>
+        </p:txBody>
+      </p:sp>
+      <p:sp>
+        <p:nvSpPr>
+          <p:cNvPr id="16" name="Text 14"/>
+          <p:cNvSpPr txBox="1"/>
+          <p:nvPr/>
+        </p:nvSpPr>
+        <p:spPr>
+          <a:xfrm>
+            <a:off x="1508760" y="4544568"/>
+            <a:ext cx="9509760" cy="685800"/>
+          </a:xfrm>
+          <a:prstGeom prst="rect">
+            <a:avLst/>
+          </a:prstGeom>
+          <a:noFill/>
+          <a:ln/>
+        </p:spPr>
+        <p:txBody>
+          <a:bodyPr wrap="square" lIns="0" tIns="0" rIns="0" bIns="0" rtlCol="0" anchor="ctr"/>
+          <a:lstStyle/>
+          <a:p>
+            <a:pPr algn="l" indent="0" marL="0">
+              <a:buNone/>
+            </a:pPr>
+            <a:r>
+              <a:rPr lang="en-US" sz="1350" dirty="0">
+                <a:solidFill>
+                  <a:srgbClr val="4E6367"/>
+                </a:solidFill>
+                <a:latin typeface="Calibri" pitchFamily="34" charset="0"/>
+                <a:ea typeface="Calibri" pitchFamily="34" charset="-122"/>
+                <a:cs typeface="Calibri" pitchFamily="34" charset="-120"/>
+              </a:rPr>
+              <a:t>Phenotype → mechanism → literature-mined approved drugs — directly applicable to the next undiagnosed rare-disease case.</a:t>
+            </a:r>
+            <a:endParaRPr lang="en-US" sz="1350" dirty="0"/>
+          </a:p>
+        </p:txBody>
+      </p:sp>
+      <p:sp>
+        <p:nvSpPr>
+          <p:cNvPr id="17" name="Shape 15"/>
+          <p:cNvSpPr/>
+          <p:nvPr/>
+        </p:nvSpPr>
+        <p:spPr>
+          <a:xfrm>
+            <a:off x="731520" y="5623560"/>
+            <a:ext cx="10698480" cy="777240"/>
+          </a:xfrm>
+          <a:prstGeom prst="roundRect">
+            <a:avLst>
+              <a:gd name="adj" fmla="val 11765"/>
+            </a:avLst>
+          </a:prstGeom>
+          <a:solidFill>
+            <a:srgbClr val="D9F0EE"/>
+          </a:solidFill>
+          <a:ln/>
+        </p:spPr>
+      </p:sp>
+      <p:sp>
+        <p:nvSpPr>
+          <p:cNvPr id="18" name="Text 16"/>
+          <p:cNvSpPr txBox="1"/>
+          <p:nvPr/>
+        </p:nvSpPr>
+        <p:spPr>
+          <a:xfrm>
+            <a:off x="1005840" y="5623560"/>
+            <a:ext cx="10149840" cy="777240"/>
+          </a:xfrm>
+          <a:prstGeom prst="rect">
+            <a:avLst/>
+          </a:prstGeom>
+          <a:noFill/>
+          <a:ln/>
+        </p:spPr>
+        <p:txBody>
+          <a:bodyPr wrap="square" lIns="0" tIns="0" rIns="0" bIns="0" rtlCol="0" anchor="ctr"/>
+          <a:lstStyle/>
+          <a:p>
+            <a:pPr algn="l" indent="0" marL="0">
+              <a:buNone/>
+            </a:pPr>
+            <a:r>
+              <a:rPr lang="en-US" sz="1250" i="1" dirty="0">
+                <a:solidFill>
+                  <a:srgbClr val="028090"/>
+                </a:solidFill>
+                <a:latin typeface="Calibri" pitchFamily="34" charset="0"/>
+                <a:ea typeface="Calibri" pitchFamily="34" charset="-122"/>
+                <a:cs typeface="Calibri" pitchFamily="34" charset="-120"/>
+              </a:rPr>
+              <a:t>Same triage logic already found this compound-het pair independently confirmed by ~20 other teams in this hackathon.</a:t>
+            </a:r>
+            <a:endParaRPr lang="en-US" sz="1250" dirty="0"/>
+          </a:p>
+        </p:txBody>
+      </p:sp>
+    </p:spTree>
+  </p:cSld>
+  <p:clrMapOvr>
+    <a:masterClrMapping/>
+  </p:clrMapOvr>
+</p:sld>
+</file>
+
+<file path=ppt/slides/slide7.xml><?xml version="1.0" encoding="utf-8"?>
+<p:sld xmlns:a="http://schemas.openxmlformats.org/drawingml/2006/main" xmlns:r="http://schemas.openxmlformats.org/officeDocument/2006/relationships" xmlns:p="http://schemas.openxmlformats.org/presentationml/2006/main">
+  <p:cSld name="Slide 7">
     <p:bg>
       <p:bgPr>
         <a:solidFill>

</xml_diff>

<commit_message>
Fix pitch deck rendering bugs found via LibreOffice visual QA
- Slide 2 table: nested text-run arrays weren't rendering in table cells
  (Change/Evidence columns were blank); replaced with plain strings.
- Slide 3 figure: variant labels overlapped the AlphaFold structure points;
  replaced with numbered markers (1, 2) + a legend below the plot.

Co-Authored-By: Claude Sonnet 5 <noreply@anthropic.com>
</commit_message>
<xml_diff>
--- a/Track 2/pitch_deck.pptx
+++ b/Track 2/pitch_deck.pptx
@@ -508,7 +508,7 @@
           <a:p>
             <a:r>
               <a:rPr lang="en-US" dirty="0"/>
-              <a:t>[0:00-0:20] This project starts with a real child living with Mosaic Variegated Aneuploidy - an ultra-rare disease with no approved treatment. In Track 1, we found a likely causal genetic diagnosis. This pitch is about what we can do with that diagnosis: two already-approved drugs worth investigating, chosen because of exactly how this disease breaks a cell, not by guessing.</a:t>
+              <a:t>[0:00-0:20] Este proyecto empieza con un niño real que vive con Aneuploidía Variegada Mosaico — una enfermedad ultra-rara sin tratamiento aprobado. En el Track 1 encontramos un diagnóstico genético probablemente causal. Esta propuesta es sobre qué podemos hacer con ese diagnóstico: dos medicamentos ya aprobados que valdría la pena investigar, elegidos por cómo exactamente esta enfermedad rompe una célula — no por adivinar.</a:t>
             </a:r>
             <a:endParaRPr lang="en-US" dirty="0"/>
           </a:p>
@@ -596,7 +596,7 @@
           <a:p>
             <a:r>
               <a:rPr lang="en-US" dirty="0"/>
-              <a:t>[0:20-0:50] The proband carries two damaged copies of BUB1B - one is a known pathogenic stop-gained variant already in ClinVar, the other a novel missense variant predicted deleterious by SIFT and PolyPhen. BUB1B encodes BUBR1, a core protein of the mitotic spindle checkpoint - the quality control system that stops a cell from dividing until every chromosome is properly attached.</a:t>
+              <a:t>[0:20-0:50] El paciente tiene dos copias dañadas del gen BUB1B — una es una variante patogénica conocida, ya registrada en ClinVar, y la otra es una variante missense nueva, predicha como dañina por SIFT y PolyPhen. BUB1B produce la proteína BUBR1, una pieza central del checkpoint del huso mitótico — el sistema de control de calidad que evita que una célula se divida hasta que cada cromosoma esté correctamente conectado.</a:t>
             </a:r>
             <a:endParaRPr lang="en-US" dirty="0"/>
           </a:p>
@@ -684,7 +684,7 @@
           <a:p>
             <a:r>
               <a:rPr lang="en-US" dirty="0"/>
-              <a:t>[0:50-1:30] When BUBR1 drops below a functional threshold, cells can no longer reliably hold the checkpoint. Chromosomes separate too early, cells end up with the wrong chromosome number, and that instability - repeated across a lifetime of cell divisions - is what predisposes these children to cancers like rhabdomyosarcoma. We confirmed this isn't just one paper's claim: we pulled the interaction network from STRING and the pathway data from Reactome, and BUB1B sits at the center of exactly this checkpoint module, independently, in both databases.</a:t>
+              <a:t>[0:50-1:30] Cuando BUBR1 baja de cierto nivel funcional, las células ya no pueden sostener ese checkpoint de forma confiable. Los cromosomas se separan demasiado pronto, las células terminan con el número equivocado de cromosomas, y esa inestabilidad — repetida a lo largo de toda una vida de divisiones celulares — es lo que predispone a estos niños a cánceres como el rabdomiosarcoma. Esto no es solo la afirmación de un paper: cruzamos la red de interacciones de STRING y las vías de Reactome, y BUB1B aparece, de forma independiente en ambas bases de datos, justo en el centro de este módulo del checkpoint.</a:t>
             </a:r>
             <a:endParaRPr lang="en-US" dirty="0"/>
           </a:p>
@@ -772,7 +772,7 @@
           <a:p>
             <a:r>
               <a:rPr lang="en-US" dirty="0"/>
-              <a:t>[1:30-2:20] So the question for Track 2 isn't 'how do we fix the checkpoint' - it's 'given a cell that already has a weak checkpoint, what already-approved drug exploits that weakness?' We found two candidates, each backed by a specific mechanistic study, not a hunch. Bosutinib, an approved leukemia drug, was shown in an independent screen to be selectively toxic to cells with a defective spindle checkpoint - exactly this cell's biology. Metformin, one of the most widely used and safest drugs in the world, was shown in a separate screen to selectively stress aneuploid cells through the AMPK energy-sensing pathway. Both are cheap, generic, and already deeply characterized in humans - which matters enormously for an ultra-rare disease with no dedicated drug pipeline. And just as important: we explicitly ruled out a whole class of drugs - checkpoint inhibitors already in cancer development - because in this patient they'd push in exactly the wrong direction.</a:t>
+              <a:t>[1:30-2:20] Entonces la pregunta para el Track 2 no es '¿cómo arreglamos el checkpoint?' — es 'dado que esta célula ya tiene un checkpoint débil, ¿qué medicamento ya aprobado explota esa debilidad?' Encontramos dos candidatos, cada uno respaldado por un estudio mecanístico específico, no una corazonada. La bosutinib, un medicamento aprobado para leucemia, demostró en un estudio independiente ser selectivamente tóxica para células con un checkpoint mitótico defectuoso — exactamente la biología de esta célula. La metformina, uno de los medicamentos más usados y más seguros del mundo, demostró en otro estudio estresar selectivamente a las células aneuploides a través de la vía de AMPK. Ambos son baratos, genéricos, y ya están profundamente caracterizados en humanos — algo enormemente importante para una enfermedad ultra-rara sin ningún desarrollo farmacéutico dedicado. Y algo igual de importante: descartamos explícitamente toda una clase de medicamentos — los inhibidores de checkpoint ya en desarrollo oncológico — porque en este paciente empujarían justo en la dirección equivocada.</a:t>
             </a:r>
             <a:endParaRPr lang="en-US" dirty="0"/>
           </a:p>
@@ -860,7 +860,7 @@
           <a:p>
             <a:r>
               <a:rPr lang="en-US" dirty="0"/>
-              <a:t>We looked for direct structural proof that bosutinib actually engages its proposed target, rather than relying on a docking prediction. PDB entry 4MXO is an experimentally solved co-crystal structure of bosutinib bound to human Src kinase - exactly the mechanism Schukken et al. showed to be selectively toxic in spindle-checkpoint-deficient cells. A separate solved structure, 3UE4, confirms bosutinib also binds Abl kinase, its other established target.</a:t>
+              <a:t>[2:20-2:35] No nos quedamos solo en el argumento mecanístico — verificamos si bosutinib realmente se une a su blanco. La entrada PDB 4MXO es una estructura resuelta por cristalografía de bosutinib unido a la quinasa Src humana — exactamente el mecanismo que Schukken et al. mostraron como selectivamente tóxico en células con checkpoint defectuoso. Otra estructura resuelta confirma que también se une a la quinasa Abl. Eso es más fuerte que una predicción de docking — es una estructura que alguien ya resolvió experimentalmente.</a:t>
             </a:r>
             <a:endParaRPr lang="en-US" dirty="0"/>
           </a:p>
@@ -948,7 +948,7 @@
           <a:p>
             <a:r>
               <a:rPr lang="en-US" dirty="0"/>
-              <a:t>[2:20-2:50] This mechanism isn't unique to this one mutation. It generalizes to the other two known MVA genes, and to chromosomally unstable tumors more broadly - the same vulnerability has independently shown up in glioblastoma and prostate cancer research. The pipeline we used - phenotype, to mechanism, to literature-mined approved drugs - is reusable for the next undiagnosed case, not just this one.</a:t>
+              <a:t>[2:35-2:50] Este mecanismo no es exclusivo de esta mutación. Se generaliza a los otros dos genes conocidos de MVA, y a tumores con inestabilidad cromosómica en general — la misma vulnerabilidad ha aparecido de forma independiente en investigación de glioblastoma y cáncer de próstata. El proceso que usamos — de fenotipo, a mecanismo, a medicamentos aprobados encontrados en la literatura — es reutilizable para el próximo caso sin diagnosticar, no solo para este.</a:t>
             </a:r>
             <a:endParaRPr lang="en-US" dirty="0"/>
           </a:p>
@@ -1036,7 +1036,7 @@
           <a:p>
             <a:r>
               <a:rPr lang="en-US" dirty="0"/>
-              <a:t>[2:50-3:00] These are hypotheses for follow-up, not proven treatments - validating them in this child's own cells is the obvious next step. But for a family that had no genetic answer six weeks ago, we think this is a real, testable place to start.</a:t>
+              <a:t>[2:50-3:00] Estas son hipótesis para investigar, no tratamientos comprobados — validarlas en las propias células de este niño es el siguiente paso obvio. Pero para una familia que hace seis semanas no tenía respuesta genética, creemos que este es un punto de partida real y comprobable.</a:t>
             </a:r>
             <a:endParaRPr lang="en-US" dirty="0"/>
           </a:p>
@@ -2310,6 +2310,17 @@
                       <a:pPr indent="0" marL="0">
                         <a:buNone/>
                       </a:pPr>
+                      <a:r>
+                        <a:rPr lang="en-US" sz="1300" dirty="0">
+                          <a:solidFill>
+                            <a:srgbClr val="1A2B2E"/>
+                          </a:solidFill>
+                          <a:latin typeface="Calibri" pitchFamily="34" charset="0"/>
+                          <a:ea typeface="Calibri" pitchFamily="34" charset="-122"/>
+                          <a:cs typeface="Calibri" pitchFamily="34" charset="-120"/>
+                        </a:rPr>
+                        <a:t>c.2210T&gt;G / p.Leu737Ter</a:t>
+                      </a:r>
                       <a:endParaRPr lang="en-US" sz="1300" dirty="0">
                         <a:latin typeface="Calibri" charset="0"/>
                         <a:ea typeface="Calibri" charset="0"/>
@@ -2354,6 +2365,9 @@
                       <a:headEnd type="none" w="med" len="med"/>
                       <a:tailEnd type="none" w="med" len="med"/>
                     </a:lnB>
+                    <a:solidFill>
+                      <a:srgbClr val="F2F9F8"/>
+                    </a:solidFill>
                   </a:tcPr>
                 </a:tc>
                 <a:tc>
@@ -2638,6 +2652,17 @@
                       <a:pPr indent="0" marL="0">
                         <a:buNone/>
                       </a:pPr>
+                      <a:r>
+                        <a:rPr lang="en-US" sz="1300" dirty="0">
+                          <a:solidFill>
+                            <a:srgbClr val="1A2B2E"/>
+                          </a:solidFill>
+                          <a:latin typeface="Calibri" pitchFamily="34" charset="0"/>
+                          <a:ea typeface="Calibri" pitchFamily="34" charset="-122"/>
+                          <a:cs typeface="Calibri" pitchFamily="34" charset="-120"/>
+                        </a:rPr>
+                        <a:t>c.3006T&gt;G / p.Asn1002Lys</a:t>
+                      </a:r>
                       <a:endParaRPr lang="en-US" sz="1300" dirty="0">
                         <a:latin typeface="Calibri" charset="0"/>
                         <a:ea typeface="Calibri" charset="0"/>
@@ -2682,6 +2707,9 @@
                       <a:headEnd type="none" w="med" len="med"/>
                       <a:tailEnd type="none" w="med" len="med"/>
                     </a:lnB>
+                    <a:solidFill>
+                      <a:srgbClr val="FFFFFF"/>
+                    </a:solidFill>
                   </a:tcPr>
                 </a:tc>
                 <a:tc>
@@ -2760,6 +2788,17 @@
                       <a:pPr indent="0" marL="0">
                         <a:buNone/>
                       </a:pPr>
+                      <a:r>
+                        <a:rPr lang="en-US" sz="1300" dirty="0">
+                          <a:solidFill>
+                            <a:srgbClr val="1A2B2E"/>
+                          </a:solidFill>
+                          <a:latin typeface="Calibri" pitchFamily="34" charset="0"/>
+                          <a:ea typeface="Calibri" pitchFamily="34" charset="-122"/>
+                          <a:cs typeface="Calibri" pitchFamily="34" charset="-120"/>
+                        </a:rPr>
+                        <a:t>SIFT + PolyPhen: deleterious</a:t>
+                      </a:r>
                       <a:endParaRPr lang="en-US" sz="1300" dirty="0">
                         <a:latin typeface="Calibri" charset="0"/>
                         <a:ea typeface="Calibri" charset="0"/>
@@ -2804,6 +2843,9 @@
                       <a:headEnd type="none" w="med" len="med"/>
                       <a:tailEnd type="none" w="med" len="med"/>
                     </a:lnB>
+                    <a:solidFill>
+                      <a:srgbClr val="FFFFFF"/>
+                    </a:solidFill>
                   </a:tcPr>
                 </a:tc>
               </a:tr>

</xml_diff>

<commit_message>
Sync PowerPoint speaker notes with the final, workshopped Spanish script
Speaker notes previously matched an earlier draft; updated all 7 slides to
match the final wording refined through user review (intro line, Tang
citation, bosutinib gender fix, simplified mechanism/closing lines).

Co-Authored-By: Claude Sonnet 5 <noreply@anthropic.com>
</commit_message>
<xml_diff>
--- a/Track 2/pitch_deck.pptx
+++ b/Track 2/pitch_deck.pptx
@@ -508,7 +508,7 @@
           <a:p>
             <a:r>
               <a:rPr lang="en-US" dirty="0"/>
-              <a:t>[0:00-0:20] Este proyecto empieza con un niño real que vive con Aneuploidía Variegada Mosaico — una enfermedad ultra-rara sin tratamiento aprobado. En el Track 1 encontramos un diagnóstico genético probablemente causal. Esta propuesta es sobre qué podemos hacer con ese diagnóstico: dos medicamentos ya aprobados que valdría la pena investigar, elegidos por cómo exactamente esta enfermedad rompe una célula — no por adivinar.</a:t>
+              <a:t>[0:00-0:20] Hola, soy el Dr. Itan H. Ruiz Hernández. Este proyecto parte de un caso real: un niño con Aneuploidía Variegada Mosaico, una enfermedad ultra-rara que hoy no tiene tratamiento. En el Track 1 llegamos a un diagnóstico genético que muy probablemente es la causa. Esta parte, el Track 2, es sobre qué hacemos con ese diagnóstico. Encontramos dos medicamentos ya aprobados que valdría la pena probar, y no porque se nos ocurrió al azar, sino porque entendimos cómo exactamente esta enfermedad daña la célula.</a:t>
             </a:r>
             <a:endParaRPr lang="en-US" dirty="0"/>
           </a:p>
@@ -596,7 +596,7 @@
           <a:p>
             <a:r>
               <a:rPr lang="en-US" dirty="0"/>
-              <a:t>[0:20-0:50] El paciente tiene dos copias dañadas del gen BUB1B — una es una variante patogénica conocida, ya registrada en ClinVar, y la otra es una variante missense nueva, predicha como dañina por SIFT y PolyPhen. BUB1B produce la proteína BUBR1, una pieza central del checkpoint del huso mitótico — el sistema de control de calidad que evita que una célula se divida hasta que cada cromosoma esté correctamente conectado.</a:t>
+              <a:t>[0:20-0:50] El niño tiene dañadas las dos copias del gen BUB1B. Una variante ya está registrada en ClinVar como patogénica. La otra es nueva, no está reportada todavía, pero SIFT y PolyPhen la predicen como dañina. BUB1B fabrica la proteína BUBR1, que es pieza clave del checkpoint del huso mitótico: básicamente el sistema que revisa que todos los cromosomas estén bien conectados antes de que la célula se divida.</a:t>
             </a:r>
             <a:endParaRPr lang="en-US" dirty="0"/>
           </a:p>
@@ -684,7 +684,7 @@
           <a:p>
             <a:r>
               <a:rPr lang="en-US" dirty="0"/>
-              <a:t>[0:50-1:30] Cuando BUBR1 baja de cierto nivel funcional, las células ya no pueden sostener ese checkpoint de forma confiable. Los cromosomas se separan demasiado pronto, las células terminan con el número equivocado de cromosomas, y esa inestabilidad — repetida a lo largo de toda una vida de divisiones celulares — es lo que predispone a estos niños a cánceres como el rabdomiosarcoma. Esto no es solo la afirmación de un paper: cruzamos la red de interacciones de STRING y las vías de Reactome, y BUB1B aparece, de forma independiente en ambas bases de datos, justo en el centro de este módulo del checkpoint.</a:t>
+              <a:t>[0:50-1:30] Cuando disminuye la cantidad de BUBR1, ese checkpoint deja de funcionar correctamente. Los cromosomas se separan antes de tiempo; la célula termina con el número equivocado de cromosomas y, con el tiempo, esa inestabilidad predispone a estos niños a cánceres como el rabdomiosarcoma. Además, revisamos esto en STRING y en Reactome, dos bases distintas, y en ambas BUB1B queda justo en el centro de esta misma vía.</a:t>
             </a:r>
             <a:endParaRPr lang="en-US" dirty="0"/>
           </a:p>
@@ -772,7 +772,7 @@
           <a:p>
             <a:r>
               <a:rPr lang="en-US" dirty="0"/>
-              <a:t>[1:30-2:20] Entonces la pregunta para el Track 2 no es '¿cómo arreglamos el checkpoint?' — es 'dado que esta célula ya tiene un checkpoint débil, ¿qué medicamento ya aprobado explota esa debilidad?' Encontramos dos candidatos, cada uno respaldado por un estudio mecanístico específico, no una corazonada. La bosutinib, un medicamento aprobado para leucemia, demostró en un estudio independiente ser selectivamente tóxica para células con un checkpoint mitótico defectuoso — exactamente la biología de esta célula. La metformina, uno de los medicamentos más usados y más seguros del mundo, demostró en otro estudio estresar selectivamente a las células aneuploides a través de la vía de AMPK. Ambos son baratos, genéricos, y ya están profundamente caracterizados en humanos — algo enormemente importante para una enfermedad ultra-rara sin ningún desarrollo farmacéutico dedicado. Y algo igual de importante: descartamos explícitamente toda una clase de medicamentos — los inhibidores de checkpoint ya en desarrollo oncológico — porque en este paciente empujarían justo en la dirección equivocada.</a:t>
+              <a:t>[1:30-2:20] Entonces para el Track 2 la pregunta no era cómo reparamos el checkpoint, sino algo distinto: si esta célula ya tiene el checkpoint débil, ¿qué medicamento aprobado se aprovecha de eso? Encontramos dos. El bosutinib, que se usa para leucemia, ya se demostró en un estudio que es tóxica específicamente para células con el checkpoint defectuoso — que es justo el caso aquí. Y la metformina, que probablemente conocen porque se usa para diabetes, en un estudio de 2011 publicado en Cell, de Tang y colaboradores, mostró que estresa selectivamente a las células aneuploides a través de AMPK. Los dos son medicamentos baratos, genéricos, con años de uso en humanos, lo cual importa mucho cuando hablamos de una enfermedad tan rara que nadie va a desarrollar un fármaco nuevo solo para ella. Y algo que decidimos descartar a propósito: los inhibidores de checkpoint que se están desarrollando para oncología. Esos van en la dirección contraria, porque aquí el checkpoint ya está débil de por sí.</a:t>
             </a:r>
             <a:endParaRPr lang="en-US" dirty="0"/>
           </a:p>
@@ -860,7 +860,7 @@
           <a:p>
             <a:r>
               <a:rPr lang="en-US" dirty="0"/>
-              <a:t>[2:20-2:35] No nos quedamos solo en el argumento mecanístico — verificamos si bosutinib realmente se une a su blanco. La entrada PDB 4MXO es una estructura resuelta por cristalografía de bosutinib unido a la quinasa Src humana — exactamente el mecanismo que Schukken et al. mostraron como selectivamente tóxico en células con checkpoint defectuoso. Otra estructura resuelta confirma que también se une a la quinasa Abl. Eso es más fuerte que una predicción de docking — es una estructura que alguien ya resolvió experimentalmente.</a:t>
+              <a:t>[2:20-2:35] Y no nos quedamos en la teoría. Buscamos si existía evidencia de que el bosutinib realmente se une a su blanco, y sí la hay: una estructura resuelta por cristalografía, con PDB 4MXO, de bosutinib unido a la quinasa Src humana. Es el mismo mecanismo que describió Schukken en 2020. Hay otra estructura que muestra que también se une a Abl. Esto no es una predicción de computadora — es algo que ya se comprobó experimentalmente.</a:t>
             </a:r>
             <a:endParaRPr lang="en-US" dirty="0"/>
           </a:p>
@@ -948,7 +948,7 @@
           <a:p>
             <a:r>
               <a:rPr lang="en-US" dirty="0"/>
-              <a:t>[2:35-2:50] Este mecanismo no es exclusivo de esta mutación. Se generaliza a los otros dos genes conocidos de MVA, y a tumores con inestabilidad cromosómica en general — la misma vulnerabilidad ha aparecido de forma independiente en investigación de glioblastoma y cáncer de próstata. El proceso que usamos — de fenotipo, a mecanismo, a medicamentos aprobados encontrados en la literatura — es reutilizable para el próximo caso sin diagnosticar, no solo para este.</a:t>
+              <a:t>[2:35-2:50] Y esto no aplica solo a esta mutación. Los otros dos genes que causan MVA llegan al mismo mecanismo, y la misma vulnerabilidad ya se ha visto en glioblastoma y en cáncer de próstata. El camino que seguimos, de fenotipo a mecanismo a fármacos ya aprobados, se puede repetir con el siguiente caso sin diagnosticar.</a:t>
             </a:r>
             <a:endParaRPr lang="en-US" dirty="0"/>
           </a:p>
@@ -1036,7 +1036,7 @@
           <a:p>
             <a:r>
               <a:rPr lang="en-US" dirty="0"/>
-              <a:t>[2:50-3:00] Estas son hipótesis para investigar, no tratamientos comprobados — validarlas en las propias células de este niño es el siguiente paso obvio. Pero para una familia que hace seis semanas no tenía respuesta genética, creemos que este es un punto de partida real y comprobable.</a:t>
+              <a:t>[2:50-3:00] Estas son hipótesis, no tratamientos comprobados. El siguiente paso sería probarlas en células del propio paciente. Pero para una familia que hace poco ni siquiera tenía un diagnóstico, consideramos que esto ya es un punto de partida real.</a:t>
             </a:r>
             <a:endParaRPr lang="en-US" dirty="0"/>
           </a:p>

</xml_diff>

<commit_message>
Switch all slide titles/subtitles to sentence case
Per user preference for presentations generally: only the first letter of
a heading is capitalized (plus proper nouns/acronyms), not Title Case.

Co-Authored-By: Claude Sonnet 5 <noreply@anthropic.com>
</commit_message>
<xml_diff>
--- a/Track 2/pitch_deck.pptx
+++ b/Track 2/pitch_deck.pptx
@@ -1521,7 +1521,7 @@
                 <a:ea typeface="Calibri" pitchFamily="34" charset="-122"/>
                 <a:cs typeface="Calibri" pitchFamily="34" charset="-120"/>
               </a:rPr>
-              <a:t>From Diagnosis to Drug Repurposing Hypothesis</a:t>
+              <a:t>From diagnosis to drug repurposing hypothesis</a:t>
             </a:r>
             <a:endParaRPr lang="en-US" sz="2200" dirty="0"/>
           </a:p>
@@ -1749,7 +1749,7 @@
                 <a:ea typeface="Cambria" pitchFamily="34" charset="-122"/>
                 <a:cs typeface="Cambria" pitchFamily="34" charset="-120"/>
               </a:rPr>
-              <a:t>Two Damaged Copies of One Gene</a:t>
+              <a:t>Two damaged copies of one gene</a:t>
             </a:r>
             <a:endParaRPr lang="en-US" sz="3000" dirty="0"/>
           </a:p>
@@ -3091,7 +3091,7 @@
                 <a:ea typeface="Cambria" pitchFamily="34" charset="-122"/>
                 <a:cs typeface="Cambria" pitchFamily="34" charset="-120"/>
               </a:rPr>
-              <a:t>How One Broken Checkpoint Causes Cancer</a:t>
+              <a:t>How one broken checkpoint causes cancer</a:t>
             </a:r>
             <a:endParaRPr lang="en-US" sz="2800" dirty="0"/>
           </a:p>
@@ -4145,7 +4145,7 @@
                 <a:ea typeface="Cambria" pitchFamily="34" charset="-122"/>
                 <a:cs typeface="Cambria" pitchFamily="34" charset="-120"/>
               </a:rPr>
-              <a:t>Two Approved Drugs, One Rationale</a:t>
+              <a:t>Two approved drugs, one rationale</a:t>
             </a:r>
             <a:endParaRPr lang="en-US" sz="2800" dirty="0"/>
           </a:p>
@@ -4787,7 +4787,7 @@
                 <a:ea typeface="Cambria" pitchFamily="34" charset="-122"/>
                 <a:cs typeface="Cambria" pitchFamily="34" charset="-120"/>
               </a:rPr>
-              <a:t>Not a Guess — A Solved Structure</a:t>
+              <a:t>Not a guess — a solved structure</a:t>
             </a:r>
             <a:endParaRPr lang="en-US" sz="2800" dirty="0"/>
           </a:p>
@@ -5452,7 +5452,7 @@
                 <a:ea typeface="Cambria" pitchFamily="34" charset="-122"/>
                 <a:cs typeface="Cambria" pitchFamily="34" charset="-120"/>
               </a:rPr>
-              <a:t>Beyond This One Child</a:t>
+              <a:t>Beyond this one child</a:t>
             </a:r>
             <a:endParaRPr lang="en-US" sz="3000" dirty="0"/>
           </a:p>
@@ -6035,7 +6035,7 @@
                 <a:ea typeface="Cambria" pitchFamily="34" charset="-122"/>
                 <a:cs typeface="Cambria" pitchFamily="34" charset="-120"/>
               </a:rPr>
-              <a:t>Hypotheses for Follow-Up,</a:t>
+              <a:t>Hypotheses for follow-up,</a:t>
             </a:r>
             <a:endParaRPr lang="en-US" sz="3800" dirty="0"/>
           </a:p>
@@ -6052,7 +6052,7 @@
                 <a:ea typeface="Cambria" pitchFamily="34" charset="-122"/>
                 <a:cs typeface="Cambria" pitchFamily="34" charset="-120"/>
               </a:rPr>
-              <a:t>Not Proven Treatments</a:t>
+              <a:t>not proven treatments</a:t>
             </a:r>
             <a:endParaRPr lang="en-US" sz="3800" dirty="0"/>
           </a:p>

</xml_diff>